<commit_message>
Update Impacts and Adaptationoptions.pptx
</commit_message>
<xml_diff>
--- a/STP/presentations/Session_3/Impacts and Adaptationoptions.pptx
+++ b/STP/presentations/Session_3/Impacts and Adaptationoptions.pptx
@@ -5,14 +5,15 @@
     <p:sldMasterId id="2147483648" r:id="rId1"/>
   </p:sldMasterIdLst>
   <p:notesMasterIdLst>
-    <p:notesMasterId r:id="rId7"/>
+    <p:notesMasterId r:id="rId8"/>
   </p:notesMasterIdLst>
   <p:sldIdLst>
     <p:sldId id="332" r:id="rId2"/>
-    <p:sldId id="316" r:id="rId3"/>
-    <p:sldId id="317" r:id="rId4"/>
-    <p:sldId id="318" r:id="rId5"/>
-    <p:sldId id="311" r:id="rId6"/>
+    <p:sldId id="333" r:id="rId3"/>
+    <p:sldId id="316" r:id="rId4"/>
+    <p:sldId id="317" r:id="rId5"/>
+    <p:sldId id="318" r:id="rId6"/>
+    <p:sldId id="311" r:id="rId7"/>
   </p:sldIdLst>
   <p:sldSz cx="12192000" cy="6858000"/>
   <p:notesSz cx="6858000" cy="9144000"/>
@@ -480,7 +481,13 @@
   <p:cSld>
     <p:spTree>
       <p:nvGrpSpPr>
-        <p:cNvPr id="1" name=""/>
+        <p:cNvPr id="1" name="">
+          <a:extLst>
+            <a:ext uri="{FF2B5EF4-FFF2-40B4-BE49-F238E27FC236}">
+              <a16:creationId xmlns:a16="http://schemas.microsoft.com/office/drawing/2014/main" id="{AC3D6885-8B1E-3EFD-2AB9-6661B5988351}"/>
+            </a:ext>
+          </a:extLst>
+        </p:cNvPr>
         <p:cNvGrpSpPr/>
         <p:nvPr/>
       </p:nvGrpSpPr>
@@ -494,7 +501,13 @@
       </p:grpSpPr>
       <p:sp>
         <p:nvSpPr>
-          <p:cNvPr id="2" name="Slide Image Placeholder 1"/>
+          <p:cNvPr id="2" name="Slide Image Placeholder 1">
+            <a:extLst>
+              <a:ext uri="{FF2B5EF4-FFF2-40B4-BE49-F238E27FC236}">
+                <a16:creationId xmlns:a16="http://schemas.microsoft.com/office/drawing/2014/main" id="{2DE223EA-D980-7236-99EF-F5CEAA2F05AC}"/>
+              </a:ext>
+            </a:extLst>
+          </p:cNvPr>
           <p:cNvSpPr>
             <a:spLocks noGrp="1" noRot="1" noChangeAspect="1"/>
           </p:cNvSpPr>
@@ -506,7 +519,13 @@
       </p:sp>
       <p:sp>
         <p:nvSpPr>
-          <p:cNvPr id="3" name="Notes Placeholder 2"/>
+          <p:cNvPr id="3" name="Notes Placeholder 2">
+            <a:extLst>
+              <a:ext uri="{FF2B5EF4-FFF2-40B4-BE49-F238E27FC236}">
+                <a16:creationId xmlns:a16="http://schemas.microsoft.com/office/drawing/2014/main" id="{3E08FF44-A1BD-099C-72F9-28DACDE499CA}"/>
+              </a:ext>
+            </a:extLst>
+          </p:cNvPr>
           <p:cNvSpPr>
             <a:spLocks noGrp="1"/>
           </p:cNvSpPr>
@@ -525,7 +544,13 @@
       </p:sp>
       <p:sp>
         <p:nvSpPr>
-          <p:cNvPr id="4" name="Slide Number Placeholder 3"/>
+          <p:cNvPr id="4" name="Slide Number Placeholder 3">
+            <a:extLst>
+              <a:ext uri="{FF2B5EF4-FFF2-40B4-BE49-F238E27FC236}">
+                <a16:creationId xmlns:a16="http://schemas.microsoft.com/office/drawing/2014/main" id="{86F16112-0EA1-4526-F645-C78C349A8050}"/>
+              </a:ext>
+            </a:extLst>
+          </p:cNvPr>
           <p:cNvSpPr>
             <a:spLocks noGrp="1"/>
           </p:cNvSpPr>
@@ -549,7 +574,7 @@
     </p:spTree>
     <p:extLst>
       <p:ext uri="{BB962C8B-B14F-4D97-AF65-F5344CB8AC3E}">
-        <p14:creationId xmlns:p14="http://schemas.microsoft.com/office/powerpoint/2010/main" val="4058098830"/>
+        <p14:creationId xmlns:p14="http://schemas.microsoft.com/office/powerpoint/2010/main" val="1467341521"/>
       </p:ext>
     </p:extLst>
   </p:cSld>
@@ -633,7 +658,7 @@
     </p:spTree>
     <p:extLst>
       <p:ext uri="{BB962C8B-B14F-4D97-AF65-F5344CB8AC3E}">
-        <p14:creationId xmlns:p14="http://schemas.microsoft.com/office/powerpoint/2010/main" val="3637039028"/>
+        <p14:creationId xmlns:p14="http://schemas.microsoft.com/office/powerpoint/2010/main" val="4058098830"/>
       </p:ext>
     </p:extLst>
   </p:cSld>
@@ -709,6 +734,90 @@
             <a:fld id="{D0D5C409-330A-754D-AD23-7502FE1ED433}" type="slidenum">
               <a:rPr lang="en-IT" smtClean="0"/>
               <a:t>4</a:t>
+            </a:fld>
+            <a:endParaRPr lang="en-IT"/>
+          </a:p>
+        </p:txBody>
+      </p:sp>
+    </p:spTree>
+    <p:extLst>
+      <p:ext uri="{BB962C8B-B14F-4D97-AF65-F5344CB8AC3E}">
+        <p14:creationId xmlns:p14="http://schemas.microsoft.com/office/powerpoint/2010/main" val="3637039028"/>
+      </p:ext>
+    </p:extLst>
+  </p:cSld>
+  <p:clrMapOvr>
+    <a:masterClrMapping/>
+  </p:clrMapOvr>
+</p:notes>
+</file>
+
+<file path=ppt/notesSlides/notesSlide4.xml><?xml version="1.0" encoding="utf-8"?>
+<p:notes xmlns:a="http://schemas.openxmlformats.org/drawingml/2006/main" xmlns:r="http://schemas.openxmlformats.org/officeDocument/2006/relationships" xmlns:p="http://schemas.openxmlformats.org/presentationml/2006/main">
+  <p:cSld>
+    <p:spTree>
+      <p:nvGrpSpPr>
+        <p:cNvPr id="1" name=""/>
+        <p:cNvGrpSpPr/>
+        <p:nvPr/>
+      </p:nvGrpSpPr>
+      <p:grpSpPr>
+        <a:xfrm>
+          <a:off x="0" y="0"/>
+          <a:ext cx="0" cy="0"/>
+          <a:chOff x="0" y="0"/>
+          <a:chExt cx="0" cy="0"/>
+        </a:xfrm>
+      </p:grpSpPr>
+      <p:sp>
+        <p:nvSpPr>
+          <p:cNvPr id="2" name="Slide Image Placeholder 1"/>
+          <p:cNvSpPr>
+            <a:spLocks noGrp="1" noRot="1" noChangeAspect="1"/>
+          </p:cNvSpPr>
+          <p:nvPr>
+            <p:ph type="sldImg"/>
+          </p:nvPr>
+        </p:nvSpPr>
+        <p:spPr/>
+      </p:sp>
+      <p:sp>
+        <p:nvSpPr>
+          <p:cNvPr id="3" name="Notes Placeholder 2"/>
+          <p:cNvSpPr>
+            <a:spLocks noGrp="1"/>
+          </p:cNvSpPr>
+          <p:nvPr>
+            <p:ph type="body" idx="1"/>
+          </p:nvPr>
+        </p:nvSpPr>
+        <p:spPr/>
+        <p:txBody>
+          <a:bodyPr/>
+          <a:lstStyle/>
+          <a:p>
+            <a:endParaRPr lang="en-IT" dirty="0"/>
+          </a:p>
+        </p:txBody>
+      </p:sp>
+      <p:sp>
+        <p:nvSpPr>
+          <p:cNvPr id="4" name="Slide Number Placeholder 3"/>
+          <p:cNvSpPr>
+            <a:spLocks noGrp="1"/>
+          </p:cNvSpPr>
+          <p:nvPr>
+            <p:ph type="sldNum" sz="quarter" idx="5"/>
+          </p:nvPr>
+        </p:nvSpPr>
+        <p:spPr/>
+        <p:txBody>
+          <a:bodyPr/>
+          <a:lstStyle/>
+          <a:p>
+            <a:fld id="{D0D5C409-330A-754D-AD23-7502FE1ED433}" type="slidenum">
+              <a:rPr lang="en-IT" smtClean="0"/>
+              <a:t>5</a:t>
             </a:fld>
             <a:endParaRPr lang="en-IT"/>
           </a:p>
@@ -4626,6 +4735,451 @@
         <p:cNvPr id="1" name="">
           <a:extLst>
             <a:ext uri="{FF2B5EF4-FFF2-40B4-BE49-F238E27FC236}">
+              <a16:creationId xmlns:a16="http://schemas.microsoft.com/office/drawing/2014/main" id="{B653B25D-9724-B083-F972-5303199EDE0F}"/>
+            </a:ext>
+          </a:extLst>
+        </p:cNvPr>
+        <p:cNvGrpSpPr/>
+        <p:nvPr/>
+      </p:nvGrpSpPr>
+      <p:grpSpPr>
+        <a:xfrm>
+          <a:off x="0" y="0"/>
+          <a:ext cx="0" cy="0"/>
+          <a:chOff x="0" y="0"/>
+          <a:chExt cx="0" cy="0"/>
+        </a:xfrm>
+      </p:grpSpPr>
+      <p:grpSp>
+        <p:nvGrpSpPr>
+          <p:cNvPr id="6" name="Group 5">
+            <a:extLst>
+              <a:ext uri="{FF2B5EF4-FFF2-40B4-BE49-F238E27FC236}">
+                <a16:creationId xmlns:a16="http://schemas.microsoft.com/office/drawing/2014/main" id="{4D3DF86C-7F1A-7ADB-CC90-CE36DB90E5DB}"/>
+              </a:ext>
+            </a:extLst>
+          </p:cNvPr>
+          <p:cNvGrpSpPr/>
+          <p:nvPr/>
+        </p:nvGrpSpPr>
+        <p:grpSpPr>
+          <a:xfrm>
+            <a:off x="-16329" y="-38779"/>
+            <a:ext cx="12393386" cy="316366"/>
+            <a:chOff x="-16329" y="5228994"/>
+            <a:chExt cx="12208329" cy="575436"/>
+          </a:xfrm>
+        </p:grpSpPr>
+        <p:sp>
+          <p:nvSpPr>
+            <p:cNvPr id="8" name="Rectangle 7">
+              <a:extLst>
+                <a:ext uri="{FF2B5EF4-FFF2-40B4-BE49-F238E27FC236}">
+                  <a16:creationId xmlns:a16="http://schemas.microsoft.com/office/drawing/2014/main" id="{B22001A8-DBE9-C39B-7B44-003C79F6418F}"/>
+                </a:ext>
+              </a:extLst>
+            </p:cNvPr>
+            <p:cNvSpPr/>
+            <p:nvPr/>
+          </p:nvSpPr>
+          <p:spPr>
+            <a:xfrm>
+              <a:off x="-16329" y="5228994"/>
+              <a:ext cx="10205358" cy="575436"/>
+            </a:xfrm>
+            <a:prstGeom prst="rect">
+              <a:avLst/>
+            </a:prstGeom>
+            <a:solidFill>
+              <a:schemeClr val="accent5">
+                <a:lumMod val="50000"/>
+              </a:schemeClr>
+            </a:solidFill>
+            <a:ln>
+              <a:noFill/>
+            </a:ln>
+          </p:spPr>
+          <p:style>
+            <a:lnRef idx="2">
+              <a:schemeClr val="accent1">
+                <a:shade val="50000"/>
+              </a:schemeClr>
+            </a:lnRef>
+            <a:fillRef idx="1">
+              <a:schemeClr val="accent1"/>
+            </a:fillRef>
+            <a:effectRef idx="0">
+              <a:schemeClr val="accent1"/>
+            </a:effectRef>
+            <a:fontRef idx="minor">
+              <a:schemeClr val="lt1"/>
+            </a:fontRef>
+          </p:style>
+          <p:txBody>
+            <a:bodyPr rtlCol="0" anchor="ctr"/>
+            <a:lstStyle/>
+            <a:p>
+              <a:pPr algn="ctr"/>
+              <a:endParaRPr lang="en-US"/>
+            </a:p>
+          </p:txBody>
+        </p:sp>
+        <p:sp>
+          <p:nvSpPr>
+            <p:cNvPr id="9" name="Rectangle 8">
+              <a:extLst>
+                <a:ext uri="{FF2B5EF4-FFF2-40B4-BE49-F238E27FC236}">
+                  <a16:creationId xmlns:a16="http://schemas.microsoft.com/office/drawing/2014/main" id="{9AD5252F-8A13-224A-AB4C-C8FF7CECB6B2}"/>
+                </a:ext>
+              </a:extLst>
+            </p:cNvPr>
+            <p:cNvSpPr/>
+            <p:nvPr/>
+          </p:nvSpPr>
+          <p:spPr>
+            <a:xfrm>
+              <a:off x="10189029" y="5228994"/>
+              <a:ext cx="2002971" cy="575435"/>
+            </a:xfrm>
+            <a:prstGeom prst="rect">
+              <a:avLst/>
+            </a:prstGeom>
+            <a:solidFill>
+              <a:schemeClr val="accent4"/>
+            </a:solidFill>
+            <a:ln>
+              <a:noFill/>
+            </a:ln>
+          </p:spPr>
+          <p:style>
+            <a:lnRef idx="2">
+              <a:schemeClr val="accent1">
+                <a:shade val="50000"/>
+              </a:schemeClr>
+            </a:lnRef>
+            <a:fillRef idx="1">
+              <a:schemeClr val="accent1"/>
+            </a:fillRef>
+            <a:effectRef idx="0">
+              <a:schemeClr val="accent1"/>
+            </a:effectRef>
+            <a:fontRef idx="minor">
+              <a:schemeClr val="lt1"/>
+            </a:fontRef>
+          </p:style>
+          <p:txBody>
+            <a:bodyPr rtlCol="0" anchor="ctr"/>
+            <a:lstStyle/>
+            <a:p>
+              <a:pPr algn="ctr"/>
+              <a:endParaRPr lang="en-US"/>
+            </a:p>
+          </p:txBody>
+        </p:sp>
+      </p:grpSp>
+      <p:cxnSp>
+        <p:nvCxnSpPr>
+          <p:cNvPr id="10" name="Connecteur droit 6">
+            <a:extLst>
+              <a:ext uri="{FF2B5EF4-FFF2-40B4-BE49-F238E27FC236}">
+                <a16:creationId xmlns:a16="http://schemas.microsoft.com/office/drawing/2014/main" id="{60175970-AB3C-4855-7ACC-D6C6DAF87583}"/>
+              </a:ext>
+            </a:extLst>
+          </p:cNvPr>
+          <p:cNvCxnSpPr>
+            <a:cxnSpLocks/>
+          </p:cNvCxnSpPr>
+          <p:nvPr/>
+        </p:nvCxnSpPr>
+        <p:spPr>
+          <a:xfrm>
+            <a:off x="-16329" y="395044"/>
+            <a:ext cx="12208329" cy="0"/>
+          </a:xfrm>
+          <a:prstGeom prst="line">
+            <a:avLst/>
+          </a:prstGeom>
+          <a:ln w="28575"/>
+        </p:spPr>
+        <p:style>
+          <a:lnRef idx="1">
+            <a:schemeClr val="accent1"/>
+          </a:lnRef>
+          <a:fillRef idx="0">
+            <a:schemeClr val="accent1"/>
+          </a:fillRef>
+          <a:effectRef idx="0">
+            <a:schemeClr val="accent1"/>
+          </a:effectRef>
+          <a:fontRef idx="minor">
+            <a:schemeClr val="tx1"/>
+          </a:fontRef>
+        </p:style>
+      </p:cxnSp>
+      <p:sp>
+        <p:nvSpPr>
+          <p:cNvPr id="2" name="TextBox 1">
+            <a:extLst>
+              <a:ext uri="{FF2B5EF4-FFF2-40B4-BE49-F238E27FC236}">
+                <a16:creationId xmlns:a16="http://schemas.microsoft.com/office/drawing/2014/main" id="{00054A6F-9C84-40FD-99E6-9FF86BCB1D59}"/>
+              </a:ext>
+            </a:extLst>
+          </p:cNvPr>
+          <p:cNvSpPr txBox="1"/>
+          <p:nvPr/>
+        </p:nvSpPr>
+        <p:spPr>
+          <a:xfrm>
+            <a:off x="393405" y="1323474"/>
+            <a:ext cx="11281144" cy="2308324"/>
+          </a:xfrm>
+          <a:prstGeom prst="rect">
+            <a:avLst/>
+          </a:prstGeom>
+          <a:noFill/>
+        </p:spPr>
+        <p:txBody>
+          <a:bodyPr wrap="square" rtlCol="0">
+            <a:spAutoFit/>
+          </a:bodyPr>
+          <a:lstStyle/>
+          <a:p>
+            <a:pPr>
+              <a:lnSpc>
+                <a:spcPct val="150000"/>
+              </a:lnSpc>
+            </a:pPr>
+            <a:r>
+              <a:rPr lang="en-GB" dirty="0" err="1"/>
+              <a:t>Discussão</a:t>
+            </a:r>
+            <a:r>
+              <a:rPr lang="en-GB" dirty="0"/>
+              <a:t> </a:t>
+            </a:r>
+            <a:r>
+              <a:rPr lang="en-GB" dirty="0" err="1"/>
+              <a:t>em</a:t>
+            </a:r>
+            <a:r>
+              <a:rPr lang="en-GB" dirty="0"/>
+              <a:t> </a:t>
+            </a:r>
+            <a:r>
+              <a:rPr lang="en-GB" dirty="0" err="1"/>
+              <a:t>grupo</a:t>
+            </a:r>
+            <a:r>
+              <a:rPr lang="en-GB" dirty="0"/>
+              <a:t> para </a:t>
+            </a:r>
+            <a:r>
+              <a:rPr lang="en-GB" dirty="0" err="1"/>
+              <a:t>vincular</a:t>
+            </a:r>
+            <a:r>
+              <a:rPr lang="en-GB" dirty="0"/>
+              <a:t> o </a:t>
+            </a:r>
+            <a:r>
+              <a:rPr lang="en-GB" dirty="0" err="1"/>
+              <a:t>resultado</a:t>
+            </a:r>
+            <a:r>
+              <a:rPr lang="en-GB" dirty="0"/>
+              <a:t> do </a:t>
+            </a:r>
+            <a:r>
+              <a:rPr lang="en-GB" dirty="0" err="1"/>
+              <a:t>estudo</a:t>
+            </a:r>
+            <a:r>
+              <a:rPr lang="en-GB" dirty="0"/>
+              <a:t> </a:t>
+            </a:r>
+            <a:r>
+              <a:rPr lang="en-GB" dirty="0" err="1"/>
+              <a:t>aos</a:t>
+            </a:r>
+            <a:r>
+              <a:rPr lang="en-GB" dirty="0"/>
+              <a:t> </a:t>
+            </a:r>
+            <a:r>
+              <a:rPr lang="en-GB" dirty="0" err="1"/>
+              <a:t>impactos</a:t>
+            </a:r>
+            <a:r>
+              <a:rPr lang="en-GB" dirty="0"/>
+              <a:t> </a:t>
+            </a:r>
+            <a:r>
+              <a:rPr lang="en-GB" dirty="0" err="1"/>
+              <a:t>socioeconômicos</a:t>
+            </a:r>
+            <a:r>
+              <a:rPr lang="en-GB" dirty="0"/>
+              <a:t> </a:t>
+            </a:r>
+            <a:r>
+              <a:rPr lang="en-GB" dirty="0" err="1"/>
+              <a:t>nas</a:t>
+            </a:r>
+            <a:r>
+              <a:rPr lang="en-GB" dirty="0"/>
+              <a:t> comunidades e </a:t>
+            </a:r>
+            <a:r>
+              <a:rPr lang="en-GB" dirty="0" err="1"/>
+              <a:t>propor</a:t>
+            </a:r>
+            <a:r>
+              <a:rPr lang="en-GB" dirty="0"/>
+              <a:t> </a:t>
+            </a:r>
+            <a:r>
+              <a:rPr lang="en-GB" dirty="0" err="1"/>
+              <a:t>opções</a:t>
+            </a:r>
+            <a:r>
+              <a:rPr lang="en-GB" dirty="0"/>
+              <a:t> de </a:t>
+            </a:r>
+            <a:r>
+              <a:rPr lang="en-GB" dirty="0" err="1"/>
+              <a:t>adaptação</a:t>
+            </a:r>
+            <a:r>
+              <a:rPr lang="en-GB" dirty="0"/>
+              <a:t>:</a:t>
+            </a:r>
+          </a:p>
+          <a:p>
+            <a:pPr marL="742950" lvl="1" indent="-285750">
+              <a:lnSpc>
+                <a:spcPct val="150000"/>
+              </a:lnSpc>
+              <a:buFont typeface="Arial" panose="020B0604020202020204" pitchFamily="34" charset="0"/>
+              <a:buChar char="•"/>
+            </a:pPr>
+            <a:r>
+              <a:rPr lang="en-GB" dirty="0"/>
+              <a:t>25 </a:t>
+            </a:r>
+            <a:r>
+              <a:rPr lang="en-GB" dirty="0" err="1"/>
+              <a:t>minutos</a:t>
+            </a:r>
+            <a:r>
+              <a:rPr lang="en-GB" dirty="0"/>
+              <a:t> no </a:t>
+            </a:r>
+            <a:r>
+              <a:rPr lang="en-GB" dirty="0" err="1"/>
+              <a:t>setor</a:t>
+            </a:r>
+            <a:r>
+              <a:rPr lang="en-GB" dirty="0"/>
+              <a:t> </a:t>
+            </a:r>
+            <a:r>
+              <a:rPr lang="en-GB" dirty="0" err="1"/>
+              <a:t>pesqueiro</a:t>
+            </a:r>
+            <a:r>
+              <a:rPr lang="en-GB" dirty="0"/>
+              <a:t>
+25 </a:t>
+            </a:r>
+            <a:r>
+              <a:rPr lang="en-GB" dirty="0" err="1"/>
+              <a:t>minutos</a:t>
+            </a:r>
+            <a:r>
+              <a:rPr lang="en-GB" dirty="0"/>
+              <a:t> no </a:t>
+            </a:r>
+            <a:r>
+              <a:rPr lang="en-GB" dirty="0" err="1"/>
+              <a:t>setor</a:t>
+            </a:r>
+            <a:r>
+              <a:rPr lang="en-GB" dirty="0"/>
+              <a:t> de turismo</a:t>
+            </a:r>
+            <a:endParaRPr lang="en-IT" dirty="0"/>
+          </a:p>
+          <a:p>
+            <a:pPr lvl="1"/>
+            <a:endParaRPr lang="en-IT" dirty="0"/>
+          </a:p>
+          <a:p>
+            <a:endParaRPr lang="en-IT" dirty="0"/>
+          </a:p>
+        </p:txBody>
+      </p:sp>
+      <p:sp>
+        <p:nvSpPr>
+          <p:cNvPr id="4" name="TextBox 3">
+            <a:extLst>
+              <a:ext uri="{FF2B5EF4-FFF2-40B4-BE49-F238E27FC236}">
+                <a16:creationId xmlns:a16="http://schemas.microsoft.com/office/drawing/2014/main" id="{88225A76-66ED-339A-6D75-61203C47BCDB}"/>
+              </a:ext>
+            </a:extLst>
+          </p:cNvPr>
+          <p:cNvSpPr txBox="1"/>
+          <p:nvPr/>
+        </p:nvSpPr>
+        <p:spPr>
+          <a:xfrm>
+            <a:off x="393405" y="4127090"/>
+            <a:ext cx="11281144" cy="467885"/>
+          </a:xfrm>
+          <a:prstGeom prst="rect">
+            <a:avLst/>
+          </a:prstGeom>
+          <a:noFill/>
+        </p:spPr>
+        <p:txBody>
+          <a:bodyPr wrap="square" rtlCol="0">
+            <a:spAutoFit/>
+          </a:bodyPr>
+          <a:lstStyle/>
+          <a:p>
+            <a:pPr>
+              <a:lnSpc>
+                <a:spcPct val="150000"/>
+              </a:lnSpc>
+            </a:pPr>
+            <a:r>
+              <a:rPr lang="it-IT"/>
+              <a:t>Apresentação dos achados (10 minutos por grupo)</a:t>
+            </a:r>
+            <a:endParaRPr lang="en-IT" dirty="0"/>
+          </a:p>
+        </p:txBody>
+      </p:sp>
+    </p:spTree>
+    <p:extLst>
+      <p:ext uri="{BB962C8B-B14F-4D97-AF65-F5344CB8AC3E}">
+        <p14:creationId xmlns:p14="http://schemas.microsoft.com/office/powerpoint/2010/main" val="3330822269"/>
+      </p:ext>
+    </p:extLst>
+  </p:cSld>
+  <p:clrMapOvr>
+    <a:masterClrMapping/>
+  </p:clrMapOvr>
+</p:sld>
+</file>
+
+<file path=ppt/slides/slide3.xml><?xml version="1.0" encoding="utf-8"?>
+<p:sld xmlns:a="http://schemas.openxmlformats.org/drawingml/2006/main" xmlns:r="http://schemas.openxmlformats.org/officeDocument/2006/relationships" xmlns:p="http://schemas.openxmlformats.org/presentationml/2006/main">
+  <p:cSld>
+    <p:spTree>
+      <p:nvGrpSpPr>
+        <p:cNvPr id="1" name="">
+          <a:extLst>
+            <a:ext uri="{FF2B5EF4-FFF2-40B4-BE49-F238E27FC236}">
               <a16:creationId xmlns:a16="http://schemas.microsoft.com/office/drawing/2014/main" id="{6EA4C62C-CE87-8D73-2F77-B62E3575F17D}"/>
             </a:ext>
           </a:extLst>
@@ -4822,7 +5376,7 @@
           <p:nvPr>
             <p:extLst>
               <p:ext uri="{D42A27DB-BD31-4B8C-83A1-F6EECF244321}">
-                <p14:modId xmlns:p14="http://schemas.microsoft.com/office/powerpoint/2010/main" val="1647459189"/>
+                <p14:modId xmlns:p14="http://schemas.microsoft.com/office/powerpoint/2010/main" val="1058880142"/>
               </p:ext>
             </p:extLst>
           </p:nvPr>
@@ -4838,14 +5392,14 @@
                 <a:tableStyleId>{5C22544A-7EE6-4342-B048-85BDC9FD1C3A}</a:tableStyleId>
               </a:tblPr>
               <a:tblGrid>
-                <a:gridCol w="1641481">
+                <a:gridCol w="1919557">
                   <a:extLst>
                     <a:ext uri="{9D8B030D-6E8A-4147-A177-3AD203B41FA5}">
                       <a16:colId xmlns:a16="http://schemas.microsoft.com/office/drawing/2014/main" val="20000"/>
                     </a:ext>
                   </a:extLst>
                 </a:gridCol>
-                <a:gridCol w="5822395">
+                <a:gridCol w="5544319">
                   <a:extLst>
                     <a:ext uri="{9D8B030D-6E8A-4147-A177-3AD203B41FA5}">
                       <a16:colId xmlns:a16="http://schemas.microsoft.com/office/drawing/2014/main" val="20002"/>
@@ -4981,23 +5535,6 @@
                         <a:tabLst/>
                         <a:defRPr/>
                       </a:pPr>
-                      <a:r>
-                        <a:rPr kumimoji="0" lang="fr-FR" sz="1800" b="1" i="0" u="none" strike="noStrike" kern="1200" cap="none" spc="0" normalizeH="0" baseline="0" noProof="0" dirty="0">
-                          <a:ln>
-                            <a:noFill/>
-                          </a:ln>
-                          <a:solidFill>
-                            <a:prstClr val="black"/>
-                          </a:solidFill>
-                          <a:effectLst/>
-                          <a:uLnTx/>
-                          <a:uFillTx/>
-                          <a:latin typeface="+mn-lt"/>
-                          <a:ea typeface="+mn-ea"/>
-                          <a:cs typeface="+mn-cs"/>
-                        </a:rPr>
-                        <a:t>1. </a:t>
-                      </a:r>
                       <a:r>
                         <a:rPr kumimoji="0" lang="pt-BR" sz="1800" b="0" i="0" u="none" strike="noStrike" kern="1200" cap="none" spc="0" normalizeH="0" baseline="0" noProof="0" dirty="0">
                           <a:ln>
@@ -5543,7 +6080,7 @@
 </p:sld>
 </file>
 
-<file path=ppt/slides/slide3.xml><?xml version="1.0" encoding="utf-8"?>
+<file path=ppt/slides/slide4.xml><?xml version="1.0" encoding="utf-8"?>
 <p:sld xmlns:a="http://schemas.openxmlformats.org/drawingml/2006/main" xmlns:r="http://schemas.openxmlformats.org/officeDocument/2006/relationships" xmlns:p="http://schemas.openxmlformats.org/presentationml/2006/main">
   <p:cSld>
     <p:spTree>
@@ -6025,7 +6562,7 @@
 </p:sld>
 </file>
 
-<file path=ppt/slides/slide4.xml><?xml version="1.0" encoding="utf-8"?>
+<file path=ppt/slides/slide5.xml><?xml version="1.0" encoding="utf-8"?>
 <p:sld xmlns:a="http://schemas.openxmlformats.org/drawingml/2006/main" xmlns:r="http://schemas.openxmlformats.org/officeDocument/2006/relationships" xmlns:p="http://schemas.openxmlformats.org/presentationml/2006/main">
   <p:cSld>
     <p:spTree>
@@ -6429,7 +6966,7 @@
 </p:sld>
 </file>
 
-<file path=ppt/slides/slide5.xml><?xml version="1.0" encoding="utf-8"?>
+<file path=ppt/slides/slide6.xml><?xml version="1.0" encoding="utf-8"?>
 <p:sld xmlns:a="http://schemas.openxmlformats.org/drawingml/2006/main" xmlns:r="http://schemas.openxmlformats.org/officeDocument/2006/relationships" xmlns:p="http://schemas.openxmlformats.org/presentationml/2006/main">
   <p:cSld>
     <p:spTree>

</xml_diff>

<commit_message>
Update local fish names
</commit_message>
<xml_diff>
--- a/STP/presentations/Session_3/Impacts and Adaptationoptions.pptx
+++ b/STP/presentations/Session_3/Impacts and Adaptationoptions.pptx
@@ -207,7 +207,7 @@
           <a:p>
             <a:fld id="{D841C4AA-CB70-1F4D-A4D0-DAC2814679D2}" type="datetimeFigureOut">
               <a:rPr lang="en-IT" smtClean="0"/>
-              <a:t>12/02/2025</a:t>
+              <a:t>12/04/2025</a:t>
             </a:fld>
             <a:endParaRPr lang="en-IT"/>
           </a:p>
@@ -900,7 +900,7 @@
           <a:p>
             <a:fld id="{F8A8B291-23C9-4CE5-96D0-E0118EB6230C}" type="datetimeFigureOut">
               <a:rPr lang="en-GB" smtClean="0"/>
-              <a:t>02/12/2025</a:t>
+              <a:t>04/12/2025</a:t>
             </a:fld>
             <a:endParaRPr lang="en-GB"/>
           </a:p>
@@ -1100,7 +1100,7 @@
           <a:p>
             <a:fld id="{F8A8B291-23C9-4CE5-96D0-E0118EB6230C}" type="datetimeFigureOut">
               <a:rPr lang="en-GB" smtClean="0"/>
-              <a:t>02/12/2025</a:t>
+              <a:t>04/12/2025</a:t>
             </a:fld>
             <a:endParaRPr lang="en-GB"/>
           </a:p>
@@ -1310,7 +1310,7 @@
           <a:p>
             <a:fld id="{F8A8B291-23C9-4CE5-96D0-E0118EB6230C}" type="datetimeFigureOut">
               <a:rPr lang="en-GB" smtClean="0"/>
-              <a:t>02/12/2025</a:t>
+              <a:t>04/12/2025</a:t>
             </a:fld>
             <a:endParaRPr lang="en-GB"/>
           </a:p>
@@ -1510,7 +1510,7 @@
           <a:p>
             <a:fld id="{F8A8B291-23C9-4CE5-96D0-E0118EB6230C}" type="datetimeFigureOut">
               <a:rPr lang="en-GB" smtClean="0"/>
-              <a:t>02/12/2025</a:t>
+              <a:t>04/12/2025</a:t>
             </a:fld>
             <a:endParaRPr lang="en-GB"/>
           </a:p>
@@ -1786,7 +1786,7 @@
           <a:p>
             <a:fld id="{F8A8B291-23C9-4CE5-96D0-E0118EB6230C}" type="datetimeFigureOut">
               <a:rPr lang="en-GB" smtClean="0"/>
-              <a:t>02/12/2025</a:t>
+              <a:t>04/12/2025</a:t>
             </a:fld>
             <a:endParaRPr lang="en-GB"/>
           </a:p>
@@ -2054,7 +2054,7 @@
           <a:p>
             <a:fld id="{F8A8B291-23C9-4CE5-96D0-E0118EB6230C}" type="datetimeFigureOut">
               <a:rPr lang="en-GB" smtClean="0"/>
-              <a:t>02/12/2025</a:t>
+              <a:t>04/12/2025</a:t>
             </a:fld>
             <a:endParaRPr lang="en-GB"/>
           </a:p>
@@ -2469,7 +2469,7 @@
           <a:p>
             <a:fld id="{F8A8B291-23C9-4CE5-96D0-E0118EB6230C}" type="datetimeFigureOut">
               <a:rPr lang="en-GB" smtClean="0"/>
-              <a:t>02/12/2025</a:t>
+              <a:t>04/12/2025</a:t>
             </a:fld>
             <a:endParaRPr lang="en-GB"/>
           </a:p>
@@ -2611,7 +2611,7 @@
           <a:p>
             <a:fld id="{F8A8B291-23C9-4CE5-96D0-E0118EB6230C}" type="datetimeFigureOut">
               <a:rPr lang="en-GB" smtClean="0"/>
-              <a:t>02/12/2025</a:t>
+              <a:t>04/12/2025</a:t>
             </a:fld>
             <a:endParaRPr lang="en-GB"/>
           </a:p>
@@ -2724,7 +2724,7 @@
           <a:p>
             <a:fld id="{F8A8B291-23C9-4CE5-96D0-E0118EB6230C}" type="datetimeFigureOut">
               <a:rPr lang="en-GB" smtClean="0"/>
-              <a:t>02/12/2025</a:t>
+              <a:t>04/12/2025</a:t>
             </a:fld>
             <a:endParaRPr lang="en-GB"/>
           </a:p>
@@ -3037,7 +3037,7 @@
           <a:p>
             <a:fld id="{F8A8B291-23C9-4CE5-96D0-E0118EB6230C}" type="datetimeFigureOut">
               <a:rPr lang="en-GB" smtClean="0"/>
-              <a:t>02/12/2025</a:t>
+              <a:t>04/12/2025</a:t>
             </a:fld>
             <a:endParaRPr lang="en-GB"/>
           </a:p>
@@ -3326,7 +3326,7 @@
           <a:p>
             <a:fld id="{F8A8B291-23C9-4CE5-96D0-E0118EB6230C}" type="datetimeFigureOut">
               <a:rPr lang="en-GB" smtClean="0"/>
-              <a:t>02/12/2025</a:t>
+              <a:t>04/12/2025</a:t>
             </a:fld>
             <a:endParaRPr lang="en-GB"/>
           </a:p>
@@ -3569,7 +3569,7 @@
           <a:p>
             <a:fld id="{F8A8B291-23C9-4CE5-96D0-E0118EB6230C}" type="datetimeFigureOut">
               <a:rPr lang="en-GB" smtClean="0"/>
-              <a:t>02/12/2025</a:t>
+              <a:t>04/12/2025</a:t>
             </a:fld>
             <a:endParaRPr lang="en-GB"/>
           </a:p>
@@ -5349,7 +5349,7 @@
           <p:nvPr>
             <p:extLst>
               <p:ext uri="{D42A27DB-BD31-4B8C-83A1-F6EECF244321}">
-                <p14:modId xmlns:p14="http://schemas.microsoft.com/office/powerpoint/2010/main" val="3647188205"/>
+                <p14:modId xmlns:p14="http://schemas.microsoft.com/office/powerpoint/2010/main" val="2226729526"/>
               </p:ext>
             </p:extLst>
           </p:nvPr>
@@ -5809,15 +5809,7 @@
                       </a:r>
                       <a:r>
                         <a:rPr lang="fr-FR" sz="1800" b="0" u="sng" dirty="0" err="1"/>
-                        <a:t>atum</a:t>
-                      </a:r>
-                      <a:r>
-                        <a:rPr lang="fr-FR" sz="1800" b="0" u="sng" dirty="0"/>
-                        <a:t> de </a:t>
-                      </a:r>
-                      <a:r>
-                        <a:rPr lang="fr-FR" sz="1800" b="0" u="sng" dirty="0" err="1"/>
-                        <a:t>barbatana</a:t>
+                        <a:t>Atum</a:t>
                       </a:r>
                       <a:r>
                         <a:rPr lang="fr-FR" sz="1800" b="0" u="sng" dirty="0"/>
@@ -5825,17 +5817,28 @@
                       </a:r>
                       <a:r>
                         <a:rPr lang="fr-FR" sz="1800" b="0" u="sng" dirty="0" err="1"/>
-                        <a:t>amarela</a:t>
+                        <a:t>judeu</a:t>
                       </a:r>
                       <a:r>
                         <a:rPr lang="fr-FR" sz="1800" b="0" u="sng" dirty="0"/>
-                        <a:t>, cavala e </a:t>
-                      </a:r>
-                      <a:r>
-                        <a:rPr lang="fr-FR" sz="1800" b="0" u="sng" dirty="0" err="1"/>
-                        <a:t>carapau</a:t>
-                      </a:r>
-                      <a:endParaRPr lang="fr-FR" sz="1800" b="0" u="sng" dirty="0"/>
+                        <a:t>, </a:t>
+                      </a:r>
+                      <a:r>
+                        <a:rPr lang="pt-PT" sz="1800" kern="1200" dirty="0">
+                          <a:solidFill>
+                            <a:schemeClr val="dk1"/>
+                          </a:solidFill>
+                          <a:effectLst/>
+                          <a:latin typeface="+mn-lt"/>
+                          <a:ea typeface="+mn-ea"/>
+                          <a:cs typeface="+mn-cs"/>
+                        </a:rPr>
+                        <a:t>peixe fumo,</a:t>
+                      </a:r>
+                      <a:r>
+                        <a:rPr lang="fr-FR" sz="1800" b="0" u="sng" dirty="0"/>
+                        <a:t> e bonito</a:t>
+                      </a:r>
                     </a:p>
                     <a:p>
                       <a:pPr marL="342900" indent="-342900">
@@ -5891,7 +5894,15 @@
                       </a:r>
                       <a:r>
                         <a:rPr lang="fr-FR" sz="1800" b="0" u="sng" dirty="0" err="1"/>
-                        <a:t>garoupas</a:t>
+                        <a:t>Badejo</a:t>
+                      </a:r>
+                      <a:r>
+                        <a:rPr lang="fr-FR" sz="1800" b="0" u="sng" dirty="0"/>
+                        <a:t> </a:t>
+                      </a:r>
+                      <a:r>
+                        <a:rPr lang="fr-FR" sz="1800" b="0" u="sng" dirty="0" err="1"/>
+                        <a:t>branco</a:t>
                       </a:r>
                       <a:r>
                         <a:rPr lang="fr-FR" sz="1800" b="0" u="sng" dirty="0"/>
@@ -5899,11 +5910,19 @@
                       </a:r>
                       <a:r>
                         <a:rPr lang="fr-FR" sz="1800" b="0" u="sng" dirty="0" err="1"/>
-                        <a:t>pargo</a:t>
+                        <a:t>corvina</a:t>
                       </a:r>
                       <a:r>
                         <a:rPr lang="fr-FR" sz="1800" b="0" u="sng" dirty="0"/>
-                        <a:t> </a:t>
+                        <a:t>, e </a:t>
+                      </a:r>
+                      <a:r>
+                        <a:rPr lang="fr-FR" sz="1800" b="0" u="sng" dirty="0" err="1"/>
+                        <a:t>corvina</a:t>
+                      </a:r>
+                      <a:r>
+                        <a:rPr lang="fr-FR" sz="1800" b="0" u="sng" dirty="0"/>
+                        <a:t> preta </a:t>
                       </a:r>
                     </a:p>
                     <a:p>
@@ -5959,6 +5978,18 @@
                         <a:t>: </a:t>
                       </a:r>
                       <a:r>
+                        <a:rPr lang="en-GB" sz="1800" b="0" i="0" u="sng" kern="1200" dirty="0">
+                          <a:solidFill>
+                            <a:schemeClr val="dk1"/>
+                          </a:solidFill>
+                          <a:effectLst/>
+                          <a:latin typeface="+mn-lt"/>
+                          <a:ea typeface="+mn-ea"/>
+                          <a:cs typeface="+mn-cs"/>
+                        </a:rPr>
+                        <a:t>Bica, </a:t>
+                      </a:r>
+                      <a:r>
                         <a:rPr lang="en-GB" sz="1800" b="0" i="0" u="sng" kern="1200" dirty="0" err="1">
                           <a:solidFill>
                             <a:schemeClr val="dk1"/>
@@ -5968,7 +5999,7 @@
                           <a:ea typeface="+mn-ea"/>
                           <a:cs typeface="+mn-cs"/>
                         </a:rPr>
-                        <a:t>Epiabo</a:t>
+                        <a:t>vermelho</a:t>
                       </a:r>
                       <a:r>
                         <a:rPr lang="en-GB" sz="1800" b="0" i="0" u="sng" kern="1200" dirty="0">
@@ -5980,8 +6011,65 @@
                           <a:ea typeface="+mn-ea"/>
                           <a:cs typeface="+mn-cs"/>
                         </a:rPr>
-                        <a:t>, Vermelho terra</a:t>
-                      </a:r>
+                        <a:t> </a:t>
+                      </a:r>
+                      <a:r>
+                        <a:rPr lang="en-GB" sz="1800" b="0" i="0" u="sng" kern="1200" dirty="0" err="1">
+                          <a:solidFill>
+                            <a:schemeClr val="dk1"/>
+                          </a:solidFill>
+                          <a:effectLst/>
+                          <a:latin typeface="+mn-lt"/>
+                          <a:ea typeface="+mn-ea"/>
+                          <a:cs typeface="+mn-cs"/>
+                        </a:rPr>
+                        <a:t>fundo</a:t>
+                      </a:r>
+                      <a:r>
+                        <a:rPr lang="en-GB" sz="1800" b="0" i="0" u="sng" kern="1200" dirty="0">
+                          <a:solidFill>
+                            <a:schemeClr val="dk1"/>
+                          </a:solidFill>
+                          <a:effectLst/>
+                          <a:latin typeface="+mn-lt"/>
+                          <a:ea typeface="+mn-ea"/>
+                          <a:cs typeface="+mn-cs"/>
+                        </a:rPr>
+                        <a:t>, b</a:t>
+                      </a:r>
+                      <a:r>
+                        <a:rPr lang="en-GB" sz="1800" b="0" i="0" kern="1200" dirty="0">
+                          <a:solidFill>
+                            <a:schemeClr val="dk1"/>
+                          </a:solidFill>
+                          <a:effectLst/>
+                          <a:latin typeface="+mn-lt"/>
+                          <a:ea typeface="+mn-ea"/>
+                          <a:cs typeface="+mn-cs"/>
+                        </a:rPr>
+                        <a:t>obo </a:t>
+                      </a:r>
+                      <a:r>
+                        <a:rPr lang="en-GB" sz="1800" b="0" i="0" kern="1200" dirty="0" err="1">
+                          <a:solidFill>
+                            <a:schemeClr val="dk1"/>
+                          </a:solidFill>
+                          <a:effectLst/>
+                          <a:latin typeface="+mn-lt"/>
+                          <a:ea typeface="+mn-ea"/>
+                          <a:cs typeface="+mn-cs"/>
+                        </a:rPr>
+                        <a:t>quema</a:t>
+                      </a:r>
+                      <a:endParaRPr lang="en-GB" sz="1800" b="0" i="0" u="sng" kern="1200" dirty="0">
+                        <a:solidFill>
+                          <a:schemeClr val="dk1"/>
+                        </a:solidFill>
+                        <a:effectLst/>
+                        <a:latin typeface="+mn-lt"/>
+                        <a:ea typeface="+mn-ea"/>
+                        <a:cs typeface="+mn-cs"/>
+                      </a:endParaRPr>
                     </a:p>
                     <a:p>
                       <a:pPr marL="342900" indent="-342900">
@@ -5999,9 +6087,22 @@
                       </a:endParaRPr>
                     </a:p>
                     <a:p>
-                      <a:pPr marL="342900" indent="-342900">
+                      <a:pPr marL="342900" marR="0" lvl="0" indent="-342900" algn="l" defTabSz="914400" rtl="0" eaLnBrk="1" fontAlgn="auto" latinLnBrk="0" hangingPunct="1">
+                        <a:lnSpc>
+                          <a:spcPct val="100000"/>
+                        </a:lnSpc>
+                        <a:spcBef>
+                          <a:spcPts val="0"/>
+                        </a:spcBef>
+                        <a:spcAft>
+                          <a:spcPts val="0"/>
+                        </a:spcAft>
+                        <a:buClrTx/>
+                        <a:buSzTx/>
                         <a:buFont typeface="+mj-lt"/>
                         <a:buAutoNum type="arabicPeriod"/>
+                        <a:tabLst/>
+                        <a:defRPr/>
                       </a:pPr>
                       <a:r>
                         <a:rPr lang="fr-FR" sz="1800" b="0" dirty="0" err="1"/>
@@ -6044,8 +6145,28 @@
                         <a:t>: </a:t>
                       </a:r>
                       <a:r>
-                        <a:rPr lang="fr-FR" sz="1800" b="0" u="sng" dirty="0" err="1"/>
-                        <a:t>carapau</a:t>
+                        <a:rPr lang="pt-PT" sz="1800" b="0" kern="1200" dirty="0">
+                          <a:solidFill>
+                            <a:schemeClr val="dk1"/>
+                          </a:solidFill>
+                          <a:effectLst/>
+                          <a:latin typeface="+mn-lt"/>
+                          <a:ea typeface="+mn-ea"/>
+                          <a:cs typeface="+mn-cs"/>
+                        </a:rPr>
+                        <a:t>B</a:t>
+                      </a:r>
+                      <a:r>
+                        <a:rPr lang="pt-PT" sz="1800" kern="1200" dirty="0">
+                          <a:solidFill>
+                            <a:schemeClr val="dk1"/>
+                          </a:solidFill>
+                          <a:effectLst/>
+                          <a:latin typeface="+mn-lt"/>
+                          <a:ea typeface="+mn-ea"/>
+                          <a:cs typeface="+mn-cs"/>
+                        </a:rPr>
+                        <a:t>onito com cauda amarela</a:t>
                       </a:r>
                       <a:r>
                         <a:rPr lang="fr-FR" sz="1800" b="0" dirty="0"/>
@@ -6061,7 +6182,19 @@
                           <a:ea typeface="+mn-ea"/>
                           <a:cs typeface="+mn-cs"/>
                         </a:rPr>
-                        <a:t>Creole-fish</a:t>
+                        <a:t>Creole-fish, </a:t>
+                      </a:r>
+                      <a:r>
+                        <a:rPr lang="en-GB" sz="1800" b="0" i="0" u="sng" kern="1200" dirty="0" err="1">
+                          <a:solidFill>
+                            <a:schemeClr val="dk1"/>
+                          </a:solidFill>
+                          <a:effectLst/>
+                          <a:latin typeface="+mn-lt"/>
+                          <a:ea typeface="+mn-ea"/>
+                          <a:cs typeface="+mn-cs"/>
+                        </a:rPr>
+                        <a:t>caqui</a:t>
                       </a:r>
                       <a:endParaRPr lang="it-IT" sz="1800" b="0" u="sng" dirty="0"/>
                     </a:p>

</xml_diff>